<commit_message>
style: paleta con contraste verificado en el deck y el dashboard
El gris que usaba para pies y subtitulos daba 2.15:1 sobre el fondo claro del
deck y 3.32:1 en el dashboard: por debajo de cualquier umbral legible.

Deck: paleta rehecha sobre blanco puro, con cada par de texto medido
-INK 18.4:1, BODY 9.2:1, SOFT 5.3:1, GREEN 7.5:1, AMBER 6.9:1 sobre blanco;
blanco 17.1:1 y PALE 14.7:1 sobre el fondo oscuro-. El gris de texto se separa
del gris de marca de grafico, que solo necesita 3:1 y ahora lo cumple.

Dashboard: --ink-3 pasa de 3.32:1 a 4.89:1 en claro y a 5.65:1 en oscuro;
--mark-out sube de 2.33:1 a 3.13:1 para que la barra se vea sobre el panel.

Co-Authored-By: Claude Opus 5 <noreply@anthropic.com>
</commit_message>
<xml_diff>
--- a/diseno/Resumen_Ejecutivo_Priorizacion_APP.pptx
+++ b/diseno/Resumen_Ejecutivo_Priorizacion_APP.pptx
@@ -145,7 +145,7 @@
           </c:tx>
           <c:spPr>
             <a:solidFill>
-              <a:srgbClr val="0B6E4F"/>
+              <a:srgbClr val="05614A"/>
             </a:solidFill>
             <a:effectLst/>
           </c:spPr>
@@ -159,7 +159,7 @@
                 <a:pPr>
                   <a:defRPr b="0" i="0" strike="noStrike" sz="1200" u="none">
                     <a:solidFill>
-                      <a:srgbClr val="0F211B"/>
+                      <a:srgbClr val="141414"/>
                     </a:solidFill>
                     <a:latin typeface="Calibri"/>
                   </a:defRPr>
@@ -251,7 +251,7 @@
               <a:pPr>
                 <a:defRPr b="0" i="0" strike="noStrike" sz="1200" u="none">
                   <a:solidFill>
-                    <a:srgbClr val="0F211B"/>
+                    <a:srgbClr val="141414"/>
                   </a:solidFill>
                   <a:latin typeface="Calibri"/>
                 </a:defRPr>
@@ -297,7 +297,7 @@
             <a:pPr>
               <a:defRPr sz="1200" b="0" i="0" u="none" strike="noStrike">
                 <a:solidFill>
-                  <a:srgbClr val="4E5C56"/>
+                  <a:srgbClr val="3F4A46"/>
                 </a:solidFill>
                 <a:latin typeface="Calibri"/>
               </a:defRPr>
@@ -401,7 +401,7 @@
           </c:tx>
           <c:spPr>
             <a:solidFill>
-              <a:srgbClr val="9FADA6"/>
+              <a:srgbClr val="8A9490"/>
             </a:solidFill>
             <a:effectLst/>
           </c:spPr>
@@ -415,7 +415,7 @@
                 <a:pPr>
                   <a:defRPr b="0" i="0" strike="noStrike" sz="1000" u="none">
                     <a:solidFill>
-                      <a:srgbClr val="4E5C56"/>
+                      <a:srgbClr val="3F4A46"/>
                     </a:solidFill>
                     <a:latin typeface="Calibri"/>
                   </a:defRPr>
@@ -514,7 +514,7 @@
           </c:tx>
           <c:spPr>
             <a:solidFill>
-              <a:srgbClr val="0B6E4F"/>
+              <a:srgbClr val="05614A"/>
             </a:solidFill>
             <a:effectLst/>
           </c:spPr>
@@ -528,7 +528,7 @@
                 <a:pPr>
                   <a:defRPr b="0" i="0" strike="noStrike" sz="1000" u="none">
                     <a:solidFill>
-                      <a:srgbClr val="4E5C56"/>
+                      <a:srgbClr val="3F4A46"/>
                     </a:solidFill>
                     <a:latin typeface="Calibri"/>
                   </a:defRPr>
@@ -620,7 +620,7 @@
               <a:pPr>
                 <a:defRPr b="0" i="0" strike="noStrike" sz="1000" u="none">
                   <a:solidFill>
-                    <a:srgbClr val="4E5C56"/>
+                    <a:srgbClr val="3F4A46"/>
                   </a:solidFill>
                   <a:latin typeface="Calibri"/>
                 </a:defRPr>
@@ -666,7 +666,7 @@
             <a:pPr>
               <a:defRPr sz="1150" b="0" i="0" u="none" strike="noStrike">
                 <a:solidFill>
-                  <a:srgbClr val="4E5C56"/>
+                  <a:srgbClr val="3F4A46"/>
                 </a:solidFill>
                 <a:latin typeface="Calibri"/>
               </a:defRPr>
@@ -736,7 +736,7 @@
           <a:pPr>
             <a:defRPr sz="1200">
               <a:solidFill>
-                <a:srgbClr val="4E5C56"/>
+                <a:srgbClr val="3F4A46"/>
               </a:solidFill>
               <a:latin typeface="Calibri"/>
               <a:cs typeface="Calibri"/>
@@ -790,7 +790,7 @@
           </c:tx>
           <c:spPr>
             <a:solidFill>
-              <a:srgbClr val="0B6E4F"/>
+              <a:srgbClr val="05614A"/>
             </a:solidFill>
             <a:effectLst/>
           </c:spPr>
@@ -804,7 +804,7 @@
                 <a:pPr>
                   <a:defRPr b="0" i="0" strike="noStrike" sz="1100" u="none">
                     <a:solidFill>
-                      <a:srgbClr val="0F211B"/>
+                      <a:srgbClr val="141414"/>
                     </a:solidFill>
                     <a:latin typeface="Calibri"/>
                   </a:defRPr>
@@ -825,7 +825,7 @@
             <c:bubble3D val="0"/>
             <c:spPr>
               <a:solidFill>
-                <a:srgbClr val="0B6E4F"/>
+                <a:srgbClr val="05614A"/>
               </a:solidFill>
               <a:effectLst/>
             </c:spPr>
@@ -836,7 +836,7 @@
             <c:bubble3D val="0"/>
             <c:spPr>
               <a:solidFill>
-                <a:srgbClr val="0B6E4F"/>
+                <a:srgbClr val="05614A"/>
               </a:solidFill>
               <a:effectLst/>
             </c:spPr>
@@ -847,7 +847,7 @@
             <c:bubble3D val="0"/>
             <c:spPr>
               <a:solidFill>
-                <a:srgbClr val="0B6E4F"/>
+                <a:srgbClr val="05614A"/>
               </a:solidFill>
               <a:effectLst/>
             </c:spPr>
@@ -858,7 +858,7 @@
             <c:bubble3D val="0"/>
             <c:spPr>
               <a:solidFill>
-                <a:srgbClr val="0B6E4F"/>
+                <a:srgbClr val="05614A"/>
               </a:solidFill>
               <a:effectLst/>
             </c:spPr>
@@ -869,7 +869,7 @@
             <c:bubble3D val="0"/>
             <c:spPr>
               <a:solidFill>
-                <a:srgbClr val="0B6E4F"/>
+                <a:srgbClr val="05614A"/>
               </a:solidFill>
               <a:effectLst/>
             </c:spPr>
@@ -880,7 +880,7 @@
             <c:bubble3D val="0"/>
             <c:spPr>
               <a:solidFill>
-                <a:srgbClr val="0B6E4F"/>
+                <a:srgbClr val="05614A"/>
               </a:solidFill>
               <a:effectLst/>
             </c:spPr>
@@ -891,7 +891,7 @@
             <c:bubble3D val="0"/>
             <c:spPr>
               <a:solidFill>
-                <a:srgbClr val="0B6E4F"/>
+                <a:srgbClr val="05614A"/>
               </a:solidFill>
               <a:effectLst/>
             </c:spPr>
@@ -902,7 +902,7 @@
             <c:bubble3D val="0"/>
             <c:spPr>
               <a:solidFill>
-                <a:srgbClr val="9A5A0F"/>
+                <a:srgbClr val="8A4A08"/>
               </a:solidFill>
               <a:effectLst/>
             </c:spPr>
@@ -984,7 +984,7 @@
               <a:pPr>
                 <a:defRPr b="0" i="0" strike="noStrike" sz="1100" u="none">
                   <a:solidFill>
-                    <a:srgbClr val="0F211B"/>
+                    <a:srgbClr val="141414"/>
                   </a:solidFill>
                   <a:latin typeface="Calibri"/>
                 </a:defRPr>
@@ -1030,7 +1030,7 @@
             <a:pPr>
               <a:defRPr sz="1150" b="0" i="0" u="none" strike="noStrike">
                 <a:solidFill>
-                  <a:srgbClr val="4E5C56"/>
+                  <a:srgbClr val="3F4A46"/>
                 </a:solidFill>
                 <a:latin typeface="Calibri"/>
               </a:defRPr>
@@ -1133,7 +1133,7 @@
           </c:tx>
           <c:spPr>
             <a:solidFill>
-              <a:srgbClr val="9FADA6"/>
+              <a:srgbClr val="8A9490"/>
             </a:solidFill>
             <a:effectLst/>
           </c:spPr>
@@ -1147,7 +1147,7 @@
                 <a:pPr>
                   <a:defRPr b="0" i="0" strike="noStrike" sz="1000" u="none">
                     <a:solidFill>
-                      <a:srgbClr val="4E5C56"/>
+                      <a:srgbClr val="3F4A46"/>
                     </a:solidFill>
                     <a:latin typeface="Calibri"/>
                   </a:defRPr>
@@ -1246,7 +1246,7 @@
           </c:tx>
           <c:spPr>
             <a:solidFill>
-              <a:srgbClr val="0B6E4F"/>
+              <a:srgbClr val="05614A"/>
             </a:solidFill>
             <a:effectLst/>
           </c:spPr>
@@ -1260,7 +1260,7 @@
                 <a:pPr>
                   <a:defRPr b="0" i="0" strike="noStrike" sz="1000" u="none">
                     <a:solidFill>
-                      <a:srgbClr val="4E5C56"/>
+                      <a:srgbClr val="3F4A46"/>
                     </a:solidFill>
                     <a:latin typeface="Calibri"/>
                   </a:defRPr>
@@ -1352,7 +1352,7 @@
               <a:pPr>
                 <a:defRPr b="0" i="0" strike="noStrike" sz="1000" u="none">
                   <a:solidFill>
-                    <a:srgbClr val="4E5C56"/>
+                    <a:srgbClr val="3F4A46"/>
                   </a:solidFill>
                   <a:latin typeface="Calibri"/>
                 </a:defRPr>
@@ -1398,7 +1398,7 @@
             <a:pPr>
               <a:defRPr sz="1150" b="0" i="0" u="none" strike="noStrike">
                 <a:solidFill>
-                  <a:srgbClr val="4E5C56"/>
+                  <a:srgbClr val="3F4A46"/>
                 </a:solidFill>
                 <a:latin typeface="Calibri"/>
               </a:defRPr>
@@ -1468,7 +1468,7 @@
           <a:pPr>
             <a:defRPr sz="1200">
               <a:solidFill>
-                <a:srgbClr val="4E5C56"/>
+                <a:srgbClr val="3F4A46"/>
               </a:solidFill>
               <a:latin typeface="Calibri"/>
               <a:cs typeface="Calibri"/>
@@ -3124,7 +3124,7 @@
     <p:bg>
       <p:bgPr>
         <a:solidFill>
-          <a:srgbClr val="0F211B"/>
+          <a:srgbClr val="0B1F1A"/>
         </a:solidFill>
       </p:bgPr>
     </p:bg>
@@ -3169,7 +3169,7 @@
             <a:r>
               <a:rPr lang="en-US" sz="1200" b="1" spc="300" kern="0" dirty="0">
                 <a:solidFill>
-                  <a:srgbClr val="2E9970"/>
+                  <a:srgbClr val="4FC49A"/>
                 </a:solidFill>
                 <a:latin typeface="Calibri" pitchFamily="34" charset="0"/>
                 <a:ea typeface="Calibri" pitchFamily="34" charset="-122"/>
@@ -3273,7 +3273,7 @@
             <a:r>
               <a:rPr lang="en-US" sz="1600" dirty="0">
                 <a:solidFill>
-                  <a:srgbClr val="DFEEE6"/>
+                  <a:srgbClr val="E6F0EC"/>
                 </a:solidFill>
                 <a:latin typeface="Calibri" pitchFamily="34" charset="0"/>
                 <a:ea typeface="Calibri" pitchFamily="34" charset="-122"/>
@@ -3312,7 +3312,7 @@
             <a:r>
               <a:rPr lang="en-US" sz="4000" b="1" dirty="0">
                 <a:solidFill>
-                  <a:srgbClr val="2E9970"/>
+                  <a:srgbClr val="4FC49A"/>
                 </a:solidFill>
                 <a:latin typeface="Cambria" pitchFamily="34" charset="0"/>
                 <a:ea typeface="Cambria" pitchFamily="34" charset="-122"/>
@@ -3390,7 +3390,7 @@
             <a:r>
               <a:rPr lang="en-US" sz="1100" dirty="0">
                 <a:solidFill>
-                  <a:srgbClr val="9FADA6"/>
+                  <a:srgbClr val="A9B5B0"/>
                 </a:solidFill>
                 <a:latin typeface="Calibri" pitchFamily="34" charset="0"/>
                 <a:ea typeface="Calibri" pitchFamily="34" charset="-122"/>
@@ -3429,7 +3429,7 @@
             <a:r>
               <a:rPr lang="en-US" sz="4000" b="1" dirty="0">
                 <a:solidFill>
-                  <a:srgbClr val="2E9970"/>
+                  <a:srgbClr val="4FC49A"/>
                 </a:solidFill>
                 <a:latin typeface="Cambria" pitchFamily="34" charset="0"/>
                 <a:ea typeface="Cambria" pitchFamily="34" charset="-122"/>
@@ -3507,7 +3507,7 @@
             <a:r>
               <a:rPr lang="en-US" sz="1100" dirty="0">
                 <a:solidFill>
-                  <a:srgbClr val="9FADA6"/>
+                  <a:srgbClr val="A9B5B0"/>
                 </a:solidFill>
                 <a:latin typeface="Calibri" pitchFamily="34" charset="0"/>
                 <a:ea typeface="Calibri" pitchFamily="34" charset="-122"/>
@@ -3546,7 +3546,7 @@
             <a:r>
               <a:rPr lang="en-US" sz="4000" b="1" dirty="0">
                 <a:solidFill>
-                  <a:srgbClr val="2E9970"/>
+                  <a:srgbClr val="4FC49A"/>
                 </a:solidFill>
                 <a:latin typeface="Cambria" pitchFamily="34" charset="0"/>
                 <a:ea typeface="Cambria" pitchFamily="34" charset="-122"/>
@@ -3624,7 +3624,7 @@
             <a:r>
               <a:rPr lang="en-US" sz="1100" dirty="0">
                 <a:solidFill>
-                  <a:srgbClr val="9FADA6"/>
+                  <a:srgbClr val="A9B5B0"/>
                 </a:solidFill>
                 <a:latin typeface="Calibri" pitchFamily="34" charset="0"/>
                 <a:ea typeface="Calibri" pitchFamily="34" charset="-122"/>
@@ -3650,7 +3650,7 @@
     <p:bg>
       <p:bgPr>
         <a:solidFill>
-          <a:srgbClr val="F4F6F3"/>
+          <a:srgbClr val="FFFFFF"/>
         </a:solidFill>
       </p:bgPr>
     </p:bg>
@@ -3695,7 +3695,7 @@
             <a:r>
               <a:rPr lang="en-US" sz="1100" b="1" spc="200" kern="0" dirty="0">
                 <a:solidFill>
-                  <a:srgbClr val="0B6E4F"/>
+                  <a:srgbClr val="05614A"/>
                 </a:solidFill>
                 <a:latin typeface="Calibri" pitchFamily="34" charset="0"/>
                 <a:ea typeface="Calibri" pitchFamily="34" charset="-122"/>
@@ -3734,7 +3734,7 @@
             <a:r>
               <a:rPr lang="en-US" sz="3400" b="1" dirty="0">
                 <a:solidFill>
-                  <a:srgbClr val="0F211B"/>
+                  <a:srgbClr val="141414"/>
                 </a:solidFill>
                 <a:latin typeface="Cambria" pitchFamily="34" charset="0"/>
                 <a:ea typeface="Cambria" pitchFamily="34" charset="-122"/>
@@ -3776,7 +3776,7 @@
             <a:r>
               <a:rPr lang="en-US" sz="1500" dirty="0">
                 <a:solidFill>
-                  <a:srgbClr val="4E5C56"/>
+                  <a:srgbClr val="3F4A46"/>
                 </a:solidFill>
                 <a:latin typeface="Calibri" pitchFamily="34" charset="0"/>
                 <a:ea typeface="Calibri" pitchFamily="34" charset="-122"/>
@@ -3809,7 +3809,7 @@
           </a:solidFill>
           <a:ln w="9525">
             <a:solidFill>
-              <a:srgbClr val="D9E0D8"/>
+              <a:srgbClr val="D3DAD7"/>
             </a:solidFill>
             <a:prstDash val="solid"/>
           </a:ln>
@@ -3842,7 +3842,7 @@
             <a:r>
               <a:rPr lang="en-US" sz="4000" b="1" dirty="0">
                 <a:solidFill>
-                  <a:srgbClr val="0B6E4F"/>
+                  <a:srgbClr val="05614A"/>
                 </a:solidFill>
                 <a:latin typeface="Cambria" pitchFamily="34" charset="0"/>
                 <a:ea typeface="Cambria" pitchFamily="34" charset="-122"/>
@@ -3884,7 +3884,7 @@
             <a:r>
               <a:rPr lang="en-US" sz="1400" b="1" dirty="0">
                 <a:solidFill>
-                  <a:srgbClr val="0F211B"/>
+                  <a:srgbClr val="141414"/>
                 </a:solidFill>
                 <a:latin typeface="Calibri" pitchFamily="34" charset="0"/>
                 <a:ea typeface="Calibri" pitchFamily="34" charset="-122"/>
@@ -3926,7 +3926,7 @@
             <a:r>
               <a:rPr lang="en-US" sz="1250" dirty="0">
                 <a:solidFill>
-                  <a:srgbClr val="4E5C56"/>
+                  <a:srgbClr val="3F4A46"/>
                 </a:solidFill>
                 <a:latin typeface="Calibri" pitchFamily="34" charset="0"/>
                 <a:ea typeface="Calibri" pitchFamily="34" charset="-122"/>
@@ -3959,7 +3959,7 @@
           </a:solidFill>
           <a:ln w="9525">
             <a:solidFill>
-              <a:srgbClr val="D9E0D8"/>
+              <a:srgbClr val="D3DAD7"/>
             </a:solidFill>
             <a:prstDash val="solid"/>
           </a:ln>
@@ -3992,7 +3992,7 @@
             <a:r>
               <a:rPr lang="en-US" sz="4000" b="1" dirty="0">
                 <a:solidFill>
-                  <a:srgbClr val="0F211B"/>
+                  <a:srgbClr val="141414"/>
                 </a:solidFill>
                 <a:latin typeface="Cambria" pitchFamily="34" charset="0"/>
                 <a:ea typeface="Cambria" pitchFamily="34" charset="-122"/>
@@ -4034,7 +4034,7 @@
             <a:r>
               <a:rPr lang="en-US" sz="1400" b="1" dirty="0">
                 <a:solidFill>
-                  <a:srgbClr val="0F211B"/>
+                  <a:srgbClr val="141414"/>
                 </a:solidFill>
                 <a:latin typeface="Calibri" pitchFamily="34" charset="0"/>
                 <a:ea typeface="Calibri" pitchFamily="34" charset="-122"/>
@@ -4076,7 +4076,7 @@
             <a:r>
               <a:rPr lang="en-US" sz="1250" dirty="0">
                 <a:solidFill>
-                  <a:srgbClr val="4E5C56"/>
+                  <a:srgbClr val="3F4A46"/>
                 </a:solidFill>
                 <a:latin typeface="Calibri" pitchFamily="34" charset="0"/>
                 <a:ea typeface="Calibri" pitchFamily="34" charset="-122"/>
@@ -4109,7 +4109,7 @@
           </a:solidFill>
           <a:ln w="9525">
             <a:solidFill>
-              <a:srgbClr val="D9E0D8"/>
+              <a:srgbClr val="D3DAD7"/>
             </a:solidFill>
             <a:prstDash val="solid"/>
           </a:ln>
@@ -4142,7 +4142,7 @@
             <a:r>
               <a:rPr lang="en-US" sz="4000" b="1" dirty="0">
                 <a:solidFill>
-                  <a:srgbClr val="9A5A0F"/>
+                  <a:srgbClr val="8A4A08"/>
                 </a:solidFill>
                 <a:latin typeface="Cambria" pitchFamily="34" charset="0"/>
                 <a:ea typeface="Cambria" pitchFamily="34" charset="-122"/>
@@ -4184,7 +4184,7 @@
             <a:r>
               <a:rPr lang="en-US" sz="1400" b="1" dirty="0">
                 <a:solidFill>
-                  <a:srgbClr val="0F211B"/>
+                  <a:srgbClr val="141414"/>
                 </a:solidFill>
                 <a:latin typeface="Calibri" pitchFamily="34" charset="0"/>
                 <a:ea typeface="Calibri" pitchFamily="34" charset="-122"/>
@@ -4226,7 +4226,7 @@
             <a:r>
               <a:rPr lang="en-US" sz="1250" dirty="0">
                 <a:solidFill>
-                  <a:srgbClr val="4E5C56"/>
+                  <a:srgbClr val="3F4A46"/>
                 </a:solidFill>
                 <a:latin typeface="Calibri" pitchFamily="34" charset="0"/>
                 <a:ea typeface="Calibri" pitchFamily="34" charset="-122"/>
@@ -4268,7 +4268,7 @@
             <a:r>
               <a:rPr lang="en-US" sz="1300" i="1" dirty="0">
                 <a:solidFill>
-                  <a:srgbClr val="4E5C56"/>
+                  <a:srgbClr val="3F4A46"/>
                 </a:solidFill>
                 <a:latin typeface="Calibri" pitchFamily="34" charset="0"/>
                 <a:ea typeface="Calibri" pitchFamily="34" charset="-122"/>
@@ -4294,7 +4294,7 @@
     <p:bg>
       <p:bgPr>
         <a:solidFill>
-          <a:srgbClr val="0F211B"/>
+          <a:srgbClr val="0B1F1A"/>
         </a:solidFill>
       </p:bgPr>
     </p:bg>
@@ -4339,7 +4339,7 @@
             <a:r>
               <a:rPr lang="en-US" sz="1200" b="1" spc="300" kern="0" dirty="0">
                 <a:solidFill>
-                  <a:srgbClr val="2E9970"/>
+                  <a:srgbClr val="4FC49A"/>
                 </a:solidFill>
                 <a:latin typeface="Calibri" pitchFamily="34" charset="0"/>
                 <a:ea typeface="Calibri" pitchFamily="34" charset="-122"/>
@@ -4420,7 +4420,7 @@
             <a:r>
               <a:rPr lang="en-US" sz="3400" b="1" dirty="0">
                 <a:solidFill>
-                  <a:srgbClr val="2E9970"/>
+                  <a:srgbClr val="4FC49A"/>
                 </a:solidFill>
                 <a:latin typeface="Cambria" pitchFamily="34" charset="0"/>
                 <a:ea typeface="Cambria" pitchFamily="34" charset="-122"/>
@@ -4462,7 +4462,7 @@
             <a:r>
               <a:rPr lang="en-US" sz="1500" dirty="0">
                 <a:solidFill>
-                  <a:srgbClr val="DFEEE6"/>
+                  <a:srgbClr val="E6F0EC"/>
                 </a:solidFill>
                 <a:latin typeface="Calibri" pitchFamily="34" charset="0"/>
                 <a:ea typeface="Calibri" pitchFamily="34" charset="-122"/>
@@ -4501,7 +4501,7 @@
             <a:r>
               <a:rPr lang="en-US" sz="3400" b="1" dirty="0">
                 <a:solidFill>
-                  <a:srgbClr val="2E9970"/>
+                  <a:srgbClr val="4FC49A"/>
                 </a:solidFill>
                 <a:latin typeface="Cambria" pitchFamily="34" charset="0"/>
                 <a:ea typeface="Cambria" pitchFamily="34" charset="-122"/>
@@ -4543,7 +4543,7 @@
             <a:r>
               <a:rPr lang="en-US" sz="1500" dirty="0">
                 <a:solidFill>
-                  <a:srgbClr val="DFEEE6"/>
+                  <a:srgbClr val="E6F0EC"/>
                 </a:solidFill>
                 <a:latin typeface="Calibri" pitchFamily="34" charset="0"/>
                 <a:ea typeface="Calibri" pitchFamily="34" charset="-122"/>
@@ -4582,7 +4582,7 @@
             <a:r>
               <a:rPr lang="en-US" sz="3400" b="1" dirty="0">
                 <a:solidFill>
-                  <a:srgbClr val="2E9970"/>
+                  <a:srgbClr val="4FC49A"/>
                 </a:solidFill>
                 <a:latin typeface="Cambria" pitchFamily="34" charset="0"/>
                 <a:ea typeface="Cambria" pitchFamily="34" charset="-122"/>
@@ -4624,7 +4624,7 @@
             <a:r>
               <a:rPr lang="en-US" sz="1500" dirty="0">
                 <a:solidFill>
-                  <a:srgbClr val="DFEEE6"/>
+                  <a:srgbClr val="E6F0EC"/>
                 </a:solidFill>
                 <a:latin typeface="Calibri" pitchFamily="34" charset="0"/>
                 <a:ea typeface="Calibri" pitchFamily="34" charset="-122"/>
@@ -4692,7 +4692,7 @@
     <p:bg>
       <p:bgPr>
         <a:solidFill>
-          <a:srgbClr val="F4F6F3"/>
+          <a:srgbClr val="FFFFFF"/>
         </a:solidFill>
       </p:bgPr>
     </p:bg>
@@ -4737,7 +4737,7 @@
             <a:r>
               <a:rPr lang="en-US" sz="1100" b="1" spc="200" kern="0" dirty="0">
                 <a:solidFill>
-                  <a:srgbClr val="0B6E4F"/>
+                  <a:srgbClr val="05614A"/>
                 </a:solidFill>
                 <a:latin typeface="Calibri" pitchFamily="34" charset="0"/>
                 <a:ea typeface="Calibri" pitchFamily="34" charset="-122"/>
@@ -4776,7 +4776,7 @@
             <a:r>
               <a:rPr lang="en-US" sz="3400" b="1" dirty="0">
                 <a:solidFill>
-                  <a:srgbClr val="0F211B"/>
+                  <a:srgbClr val="141414"/>
                 </a:solidFill>
                 <a:latin typeface="Cambria" pitchFamily="34" charset="0"/>
                 <a:ea typeface="Cambria" pitchFamily="34" charset="-122"/>
@@ -4818,7 +4818,7 @@
             <a:r>
               <a:rPr lang="en-US" sz="1500" dirty="0">
                 <a:solidFill>
-                  <a:srgbClr val="4E5C56"/>
+                  <a:srgbClr val="3F4A46"/>
                 </a:solidFill>
                 <a:latin typeface="Calibri" pitchFamily="34" charset="0"/>
                 <a:ea typeface="Calibri" pitchFamily="34" charset="-122"/>
@@ -4847,11 +4847,11 @@
             </a:avLst>
           </a:prstGeom>
           <a:solidFill>
-            <a:srgbClr val="F4F6F3"/>
+            <a:srgbClr val="F5F7F6"/>
           </a:solidFill>
           <a:ln w="9525">
             <a:solidFill>
-              <a:srgbClr val="D9E0D8"/>
+              <a:srgbClr val="D3DAD7"/>
             </a:solidFill>
             <a:prstDash val="solid"/>
           </a:ln>
@@ -4884,7 +4884,7 @@
             <a:r>
               <a:rPr lang="en-US" sz="2100" b="1" dirty="0">
                 <a:solidFill>
-                  <a:srgbClr val="9FADA6"/>
+                  <a:srgbClr val="5A625E"/>
                 </a:solidFill>
                 <a:latin typeface="Cambria" pitchFamily="34" charset="0"/>
                 <a:ea typeface="Cambria" pitchFamily="34" charset="-122"/>
@@ -4911,7 +4911,7 @@
             <a:avLst/>
           </a:prstGeom>
           <a:solidFill>
-            <a:srgbClr val="9FADA6"/>
+            <a:srgbClr val="5A625E"/>
           </a:solidFill>
           <a:ln/>
         </p:spPr>
@@ -4974,7 +4974,7 @@
             <a:r>
               <a:rPr lang="en-US" sz="1350" dirty="0">
                 <a:solidFill>
-                  <a:srgbClr val="4E5C56"/>
+                  <a:srgbClr val="3F4A46"/>
                 </a:solidFill>
                 <a:latin typeface="Calibri" pitchFamily="34" charset="0"/>
                 <a:ea typeface="Calibri" pitchFamily="34" charset="-122"/>
@@ -5001,7 +5001,7 @@
             <a:avLst/>
           </a:prstGeom>
           <a:solidFill>
-            <a:srgbClr val="9FADA6"/>
+            <a:srgbClr val="5A625E"/>
           </a:solidFill>
           <a:ln/>
         </p:spPr>
@@ -5064,7 +5064,7 @@
             <a:r>
               <a:rPr lang="en-US" sz="1350" dirty="0">
                 <a:solidFill>
-                  <a:srgbClr val="4E5C56"/>
+                  <a:srgbClr val="3F4A46"/>
                 </a:solidFill>
                 <a:latin typeface="Calibri" pitchFamily="34" charset="0"/>
                 <a:ea typeface="Calibri" pitchFamily="34" charset="-122"/>
@@ -5091,7 +5091,7 @@
             <a:avLst/>
           </a:prstGeom>
           <a:solidFill>
-            <a:srgbClr val="9FADA6"/>
+            <a:srgbClr val="5A625E"/>
           </a:solidFill>
           <a:ln/>
         </p:spPr>
@@ -5154,7 +5154,7 @@
             <a:r>
               <a:rPr lang="en-US" sz="1350" dirty="0">
                 <a:solidFill>
-                  <a:srgbClr val="4E5C56"/>
+                  <a:srgbClr val="3F4A46"/>
                 </a:solidFill>
                 <a:latin typeface="Calibri" pitchFamily="34" charset="0"/>
                 <a:ea typeface="Calibri" pitchFamily="34" charset="-122"/>
@@ -5181,7 +5181,7 @@
             <a:avLst/>
           </a:prstGeom>
           <a:solidFill>
-            <a:srgbClr val="9FADA6"/>
+            <a:srgbClr val="5A625E"/>
           </a:solidFill>
           <a:ln/>
         </p:spPr>
@@ -5244,7 +5244,7 @@
             <a:r>
               <a:rPr lang="en-US" sz="1350" dirty="0">
                 <a:solidFill>
-                  <a:srgbClr val="4E5C56"/>
+                  <a:srgbClr val="3F4A46"/>
                 </a:solidFill>
                 <a:latin typeface="Calibri" pitchFamily="34" charset="0"/>
                 <a:ea typeface="Calibri" pitchFamily="34" charset="-122"/>
@@ -5277,7 +5277,7 @@
           </a:solidFill>
           <a:ln w="9525">
             <a:solidFill>
-              <a:srgbClr val="D9E0D8"/>
+              <a:srgbClr val="D3DAD7"/>
             </a:solidFill>
             <a:prstDash val="solid"/>
           </a:ln>
@@ -5310,7 +5310,7 @@
             <a:r>
               <a:rPr lang="en-US" sz="2100" b="1" dirty="0">
                 <a:solidFill>
-                  <a:srgbClr val="0B6E4F"/>
+                  <a:srgbClr val="05614A"/>
                 </a:solidFill>
                 <a:latin typeface="Cambria" pitchFamily="34" charset="0"/>
                 <a:ea typeface="Cambria" pitchFamily="34" charset="-122"/>
@@ -5337,7 +5337,7 @@
             <a:avLst/>
           </a:prstGeom>
           <a:solidFill>
-            <a:srgbClr val="0B6E4F"/>
+            <a:srgbClr val="05614A"/>
           </a:solidFill>
           <a:ln/>
         </p:spPr>
@@ -5400,7 +5400,7 @@
             <a:r>
               <a:rPr lang="en-US" sz="1350" dirty="0">
                 <a:solidFill>
-                  <a:srgbClr val="0F211B"/>
+                  <a:srgbClr val="141414"/>
                 </a:solidFill>
                 <a:latin typeface="Calibri" pitchFamily="34" charset="0"/>
                 <a:ea typeface="Calibri" pitchFamily="34" charset="-122"/>
@@ -5427,7 +5427,7 @@
             <a:avLst/>
           </a:prstGeom>
           <a:solidFill>
-            <a:srgbClr val="0B6E4F"/>
+            <a:srgbClr val="05614A"/>
           </a:solidFill>
           <a:ln/>
         </p:spPr>
@@ -5490,7 +5490,7 @@
             <a:r>
               <a:rPr lang="en-US" sz="1350" dirty="0">
                 <a:solidFill>
-                  <a:srgbClr val="0F211B"/>
+                  <a:srgbClr val="141414"/>
                 </a:solidFill>
                 <a:latin typeface="Calibri" pitchFamily="34" charset="0"/>
                 <a:ea typeface="Calibri" pitchFamily="34" charset="-122"/>
@@ -5517,7 +5517,7 @@
             <a:avLst/>
           </a:prstGeom>
           <a:solidFill>
-            <a:srgbClr val="0B6E4F"/>
+            <a:srgbClr val="05614A"/>
           </a:solidFill>
           <a:ln/>
         </p:spPr>
@@ -5580,7 +5580,7 @@
             <a:r>
               <a:rPr lang="en-US" sz="1350" dirty="0">
                 <a:solidFill>
-                  <a:srgbClr val="0F211B"/>
+                  <a:srgbClr val="141414"/>
                 </a:solidFill>
                 <a:latin typeface="Calibri" pitchFamily="34" charset="0"/>
                 <a:ea typeface="Calibri" pitchFamily="34" charset="-122"/>
@@ -5607,7 +5607,7 @@
             <a:avLst/>
           </a:prstGeom>
           <a:solidFill>
-            <a:srgbClr val="0B6E4F"/>
+            <a:srgbClr val="05614A"/>
           </a:solidFill>
           <a:ln/>
         </p:spPr>
@@ -5670,7 +5670,7 @@
             <a:r>
               <a:rPr lang="en-US" sz="1350" dirty="0">
                 <a:solidFill>
-                  <a:srgbClr val="0F211B"/>
+                  <a:srgbClr val="141414"/>
                 </a:solidFill>
                 <a:latin typeface="Calibri" pitchFamily="34" charset="0"/>
                 <a:ea typeface="Calibri" pitchFamily="34" charset="-122"/>
@@ -5709,7 +5709,7 @@
             <a:r>
               <a:rPr lang="en-US" sz="1000" dirty="0">
                 <a:solidFill>
-                  <a:srgbClr val="9FADA6"/>
+                  <a:srgbClr val="646E6A"/>
                 </a:solidFill>
                 <a:latin typeface="Calibri" pitchFamily="34" charset="0"/>
                 <a:ea typeface="Calibri" pitchFamily="34" charset="-122"/>
@@ -5735,7 +5735,7 @@
     <p:bg>
       <p:bgPr>
         <a:solidFill>
-          <a:srgbClr val="F4F6F3"/>
+          <a:srgbClr val="FFFFFF"/>
         </a:solidFill>
       </p:bgPr>
     </p:bg>
@@ -5780,7 +5780,7 @@
             <a:r>
               <a:rPr lang="en-US" sz="1100" b="1" spc="200" kern="0" dirty="0">
                 <a:solidFill>
-                  <a:srgbClr val="0B6E4F"/>
+                  <a:srgbClr val="05614A"/>
                 </a:solidFill>
                 <a:latin typeface="Calibri" pitchFamily="34" charset="0"/>
                 <a:ea typeface="Calibri" pitchFamily="34" charset="-122"/>
@@ -5819,7 +5819,7 @@
             <a:r>
               <a:rPr lang="en-US" sz="3400" b="1" dirty="0">
                 <a:solidFill>
-                  <a:srgbClr val="0F211B"/>
+                  <a:srgbClr val="141414"/>
                 </a:solidFill>
                 <a:latin typeface="Cambria" pitchFamily="34" charset="0"/>
                 <a:ea typeface="Cambria" pitchFamily="34" charset="-122"/>
@@ -5852,7 +5852,7 @@
           </a:solidFill>
           <a:ln w="9525">
             <a:solidFill>
-              <a:srgbClr val="D9E0D8"/>
+              <a:srgbClr val="D3DAD7"/>
             </a:solidFill>
             <a:prstDash val="solid"/>
           </a:ln>
@@ -5873,7 +5873,7 @@
             <a:avLst/>
           </a:prstGeom>
           <a:solidFill>
-            <a:srgbClr val="0B6E4F"/>
+            <a:srgbClr val="05614A"/>
           </a:solidFill>
           <a:ln/>
         </p:spPr>
@@ -5944,7 +5944,7 @@
             <a:r>
               <a:rPr lang="en-US" sz="2000" b="1" dirty="0">
                 <a:solidFill>
-                  <a:srgbClr val="0F211B"/>
+                  <a:srgbClr val="141414"/>
                 </a:solidFill>
                 <a:latin typeface="Cambria" pitchFamily="34" charset="0"/>
                 <a:ea typeface="Cambria" pitchFamily="34" charset="-122"/>
@@ -5986,7 +5986,7 @@
             <a:r>
               <a:rPr lang="en-US" sz="1350" dirty="0">
                 <a:solidFill>
-                  <a:srgbClr val="4E5C56"/>
+                  <a:srgbClr val="3F4A46"/>
                 </a:solidFill>
                 <a:latin typeface="Calibri" pitchFamily="34" charset="0"/>
                 <a:ea typeface="Calibri" pitchFamily="34" charset="-122"/>
@@ -6015,7 +6015,7 @@
             </a:avLst>
           </a:prstGeom>
           <a:solidFill>
-            <a:srgbClr val="DFEEE6"/>
+            <a:srgbClr val="E6F0EC"/>
           </a:solidFill>
           <a:ln/>
         </p:spPr>
@@ -6047,7 +6047,7 @@
             <a:r>
               <a:rPr lang="en-US" sz="1250" b="1" dirty="0">
                 <a:solidFill>
-                  <a:srgbClr val="0B6E4F"/>
+                  <a:srgbClr val="05614A"/>
                 </a:solidFill>
                 <a:latin typeface="Calibri" pitchFamily="34" charset="0"/>
                 <a:ea typeface="Calibri" pitchFamily="34" charset="-122"/>
@@ -6080,7 +6080,7 @@
           </a:solidFill>
           <a:ln w="9525">
             <a:solidFill>
-              <a:srgbClr val="D9E0D8"/>
+              <a:srgbClr val="D3DAD7"/>
             </a:solidFill>
             <a:prstDash val="solid"/>
           </a:ln>
@@ -6101,7 +6101,7 @@
             <a:avLst/>
           </a:prstGeom>
           <a:solidFill>
-            <a:srgbClr val="0B6E4F"/>
+            <a:srgbClr val="05614A"/>
           </a:solidFill>
           <a:ln/>
         </p:spPr>
@@ -6172,7 +6172,7 @@
             <a:r>
               <a:rPr lang="en-US" sz="2000" b="1" dirty="0">
                 <a:solidFill>
-                  <a:srgbClr val="0F211B"/>
+                  <a:srgbClr val="141414"/>
                 </a:solidFill>
                 <a:latin typeface="Cambria" pitchFamily="34" charset="0"/>
                 <a:ea typeface="Cambria" pitchFamily="34" charset="-122"/>
@@ -6214,7 +6214,7 @@
             <a:r>
               <a:rPr lang="en-US" sz="1350" dirty="0">
                 <a:solidFill>
-                  <a:srgbClr val="4E5C56"/>
+                  <a:srgbClr val="3F4A46"/>
                 </a:solidFill>
                 <a:latin typeface="Calibri" pitchFamily="34" charset="0"/>
                 <a:ea typeface="Calibri" pitchFamily="34" charset="-122"/>
@@ -6243,7 +6243,7 @@
             </a:avLst>
           </a:prstGeom>
           <a:solidFill>
-            <a:srgbClr val="DFEEE6"/>
+            <a:srgbClr val="E6F0EC"/>
           </a:solidFill>
           <a:ln/>
         </p:spPr>
@@ -6275,7 +6275,7 @@
             <a:r>
               <a:rPr lang="en-US" sz="1250" b="1" dirty="0">
                 <a:solidFill>
-                  <a:srgbClr val="0B6E4F"/>
+                  <a:srgbClr val="05614A"/>
                 </a:solidFill>
                 <a:latin typeface="Calibri" pitchFamily="34" charset="0"/>
                 <a:ea typeface="Calibri" pitchFamily="34" charset="-122"/>
@@ -6302,7 +6302,7 @@
             <a:avLst/>
           </a:prstGeom>
           <a:solidFill>
-            <a:srgbClr val="0B6E4F"/>
+            <a:srgbClr val="05614A"/>
           </a:solidFill>
           <a:ln/>
         </p:spPr>
@@ -6337,7 +6337,7 @@
             <a:r>
               <a:rPr lang="en-US" sz="1300" i="1" dirty="0">
                 <a:solidFill>
-                  <a:srgbClr val="4E5C56"/>
+                  <a:srgbClr val="3F4A46"/>
                 </a:solidFill>
                 <a:latin typeface="Calibri" pitchFamily="34" charset="0"/>
                 <a:ea typeface="Calibri" pitchFamily="34" charset="-122"/>
@@ -6363,7 +6363,7 @@
     <p:bg>
       <p:bgPr>
         <a:solidFill>
-          <a:srgbClr val="F4F6F3"/>
+          <a:srgbClr val="FFFFFF"/>
         </a:solidFill>
       </p:bgPr>
     </p:bg>
@@ -6408,7 +6408,7 @@
             <a:r>
               <a:rPr lang="en-US" sz="1100" b="1" spc="200" kern="0" dirty="0">
                 <a:solidFill>
-                  <a:srgbClr val="0B6E4F"/>
+                  <a:srgbClr val="05614A"/>
                 </a:solidFill>
                 <a:latin typeface="Calibri" pitchFamily="34" charset="0"/>
                 <a:ea typeface="Calibri" pitchFamily="34" charset="-122"/>
@@ -6447,7 +6447,7 @@
             <a:r>
               <a:rPr lang="en-US" sz="3400" b="1" dirty="0">
                 <a:solidFill>
-                  <a:srgbClr val="0F211B"/>
+                  <a:srgbClr val="141414"/>
                 </a:solidFill>
                 <a:latin typeface="Cambria" pitchFamily="34" charset="0"/>
                 <a:ea typeface="Cambria" pitchFamily="34" charset="-122"/>
@@ -6489,7 +6489,7 @@
             <a:r>
               <a:rPr lang="en-US" sz="1500" dirty="0">
                 <a:solidFill>
-                  <a:srgbClr val="4E5C56"/>
+                  <a:srgbClr val="3F4A46"/>
                 </a:solidFill>
                 <a:latin typeface="Calibri" pitchFamily="34" charset="0"/>
                 <a:ea typeface="Calibri" pitchFamily="34" charset="-122"/>
@@ -6538,7 +6538,7 @@
           </a:solidFill>
           <a:ln w="9525">
             <a:solidFill>
-              <a:srgbClr val="D9E0D8"/>
+              <a:srgbClr val="D3DAD7"/>
             </a:solidFill>
             <a:prstDash val="solid"/>
           </a:ln>
@@ -6571,7 +6571,7 @@
             <a:r>
               <a:rPr lang="en-US" sz="1200" b="1" spc="100" kern="0" dirty="0">
                 <a:solidFill>
-                  <a:srgbClr val="4E5C56"/>
+                  <a:srgbClr val="3F4A46"/>
                 </a:solidFill>
                 <a:latin typeface="Calibri" pitchFamily="34" charset="0"/>
                 <a:ea typeface="Calibri" pitchFamily="34" charset="-122"/>
@@ -6610,7 +6610,7 @@
             <a:r>
               <a:rPr lang="en-US" sz="4400" b="1" dirty="0">
                 <a:solidFill>
-                  <a:srgbClr val="0B6E4F"/>
+                  <a:srgbClr val="05614A"/>
                 </a:solidFill>
                 <a:latin typeface="Cambria" pitchFamily="34" charset="0"/>
                 <a:ea typeface="Cambria" pitchFamily="34" charset="-122"/>
@@ -6652,7 +6652,7 @@
             <a:r>
               <a:rPr lang="en-US" sz="1250" dirty="0">
                 <a:solidFill>
-                  <a:srgbClr val="4E5C56"/>
+                  <a:srgbClr val="3F4A46"/>
                 </a:solidFill>
                 <a:latin typeface="Calibri" pitchFamily="34" charset="0"/>
                 <a:ea typeface="Calibri" pitchFamily="34" charset="-122"/>
@@ -6691,7 +6691,7 @@
             <a:r>
               <a:rPr lang="en-US" sz="1200" b="1" spc="100" kern="0" dirty="0">
                 <a:solidFill>
-                  <a:srgbClr val="4E5C56"/>
+                  <a:srgbClr val="3F4A46"/>
                 </a:solidFill>
                 <a:latin typeface="Calibri" pitchFamily="34" charset="0"/>
                 <a:ea typeface="Calibri" pitchFamily="34" charset="-122"/>
@@ -6730,7 +6730,7 @@
             <a:r>
               <a:rPr lang="en-US" sz="3400" b="1" dirty="0">
                 <a:solidFill>
-                  <a:srgbClr val="9A5A0F"/>
+                  <a:srgbClr val="8A4A08"/>
                 </a:solidFill>
                 <a:latin typeface="Cambria" pitchFamily="34" charset="0"/>
                 <a:ea typeface="Cambria" pitchFamily="34" charset="-122"/>
@@ -6772,7 +6772,7 @@
             <a:r>
               <a:rPr lang="en-US" sz="1250" dirty="0">
                 <a:solidFill>
-                  <a:srgbClr val="4E5C56"/>
+                  <a:srgbClr val="3F4A46"/>
                 </a:solidFill>
                 <a:latin typeface="Calibri" pitchFamily="34" charset="0"/>
                 <a:ea typeface="Calibri" pitchFamily="34" charset="-122"/>
@@ -6792,7 +6792,7 @@
             <a:r>
               <a:rPr lang="en-US" sz="1250" dirty="0">
                 <a:solidFill>
-                  <a:srgbClr val="4E5C56"/>
+                  <a:srgbClr val="3F4A46"/>
                 </a:solidFill>
                 <a:latin typeface="Calibri" pitchFamily="34" charset="0"/>
                 <a:ea typeface="Calibri" pitchFamily="34" charset="-122"/>
@@ -6818,7 +6818,7 @@
     <p:bg>
       <p:bgPr>
         <a:solidFill>
-          <a:srgbClr val="F4F6F3"/>
+          <a:srgbClr val="FFFFFF"/>
         </a:solidFill>
       </p:bgPr>
     </p:bg>
@@ -6863,7 +6863,7 @@
             <a:r>
               <a:rPr lang="en-US" sz="1100" b="1" spc="200" kern="0" dirty="0">
                 <a:solidFill>
-                  <a:srgbClr val="0B6E4F"/>
+                  <a:srgbClr val="05614A"/>
                 </a:solidFill>
                 <a:latin typeface="Calibri" pitchFamily="34" charset="0"/>
                 <a:ea typeface="Calibri" pitchFamily="34" charset="-122"/>
@@ -6902,7 +6902,7 @@
             <a:r>
               <a:rPr lang="en-US" sz="3400" b="1" dirty="0">
                 <a:solidFill>
-                  <a:srgbClr val="0F211B"/>
+                  <a:srgbClr val="141414"/>
                 </a:solidFill>
                 <a:latin typeface="Cambria" pitchFamily="34" charset="0"/>
                 <a:ea typeface="Cambria" pitchFamily="34" charset="-122"/>
@@ -6935,7 +6935,7 @@
           </a:solidFill>
           <a:ln w="9525">
             <a:solidFill>
-              <a:srgbClr val="D9E0D8"/>
+              <a:srgbClr val="D3DAD7"/>
             </a:solidFill>
             <a:prstDash val="solid"/>
           </a:ln>
@@ -6956,7 +6956,7 @@
             <a:avLst/>
           </a:prstGeom>
           <a:solidFill>
-            <a:srgbClr val="0B6E4F"/>
+            <a:srgbClr val="05614A"/>
           </a:solidFill>
           <a:ln/>
         </p:spPr>
@@ -7027,7 +7027,7 @@
             <a:r>
               <a:rPr lang="en-US" sz="1900" b="1" dirty="0">
                 <a:solidFill>
-                  <a:srgbClr val="0F211B"/>
+                  <a:srgbClr val="141414"/>
                 </a:solidFill>
                 <a:latin typeface="Cambria" pitchFamily="34" charset="0"/>
                 <a:ea typeface="Cambria" pitchFamily="34" charset="-122"/>
@@ -7069,7 +7069,7 @@
             <a:r>
               <a:rPr lang="en-US" sz="1250" dirty="0">
                 <a:solidFill>
-                  <a:srgbClr val="4E5C56"/>
+                  <a:srgbClr val="3F4A46"/>
                 </a:solidFill>
                 <a:latin typeface="Calibri" pitchFamily="34" charset="0"/>
                 <a:ea typeface="Calibri" pitchFamily="34" charset="-122"/>
@@ -7102,7 +7102,7 @@
           </a:solidFill>
           <a:ln w="9525">
             <a:solidFill>
-              <a:srgbClr val="D9E0D8"/>
+              <a:srgbClr val="D3DAD7"/>
             </a:solidFill>
             <a:prstDash val="solid"/>
           </a:ln>
@@ -7123,7 +7123,7 @@
             <a:avLst/>
           </a:prstGeom>
           <a:solidFill>
-            <a:srgbClr val="0B6E4F"/>
+            <a:srgbClr val="05614A"/>
           </a:solidFill>
           <a:ln/>
         </p:spPr>
@@ -7194,7 +7194,7 @@
             <a:r>
               <a:rPr lang="en-US" sz="1900" b="1" dirty="0">
                 <a:solidFill>
-                  <a:srgbClr val="0F211B"/>
+                  <a:srgbClr val="141414"/>
                 </a:solidFill>
                 <a:latin typeface="Cambria" pitchFamily="34" charset="0"/>
                 <a:ea typeface="Cambria" pitchFamily="34" charset="-122"/>
@@ -7236,7 +7236,7 @@
             <a:r>
               <a:rPr lang="en-US" sz="1250" dirty="0">
                 <a:solidFill>
-                  <a:srgbClr val="4E5C56"/>
+                  <a:srgbClr val="3F4A46"/>
                 </a:solidFill>
                 <a:latin typeface="Calibri" pitchFamily="34" charset="0"/>
                 <a:ea typeface="Calibri" pitchFamily="34" charset="-122"/>
@@ -7269,7 +7269,7 @@
           </a:solidFill>
           <a:ln w="9525">
             <a:solidFill>
-              <a:srgbClr val="D9E0D8"/>
+              <a:srgbClr val="D3DAD7"/>
             </a:solidFill>
             <a:prstDash val="solid"/>
           </a:ln>
@@ -7290,7 +7290,7 @@
             <a:avLst/>
           </a:prstGeom>
           <a:solidFill>
-            <a:srgbClr val="0B6E4F"/>
+            <a:srgbClr val="05614A"/>
           </a:solidFill>
           <a:ln/>
         </p:spPr>
@@ -7361,7 +7361,7 @@
             <a:r>
               <a:rPr lang="en-US" sz="1900" b="1" dirty="0">
                 <a:solidFill>
-                  <a:srgbClr val="0F211B"/>
+                  <a:srgbClr val="141414"/>
                 </a:solidFill>
                 <a:latin typeface="Cambria" pitchFamily="34" charset="0"/>
                 <a:ea typeface="Cambria" pitchFamily="34" charset="-122"/>
@@ -7403,7 +7403,7 @@
             <a:r>
               <a:rPr lang="en-US" sz="1250" dirty="0">
                 <a:solidFill>
-                  <a:srgbClr val="4E5C56"/>
+                  <a:srgbClr val="3F4A46"/>
                 </a:solidFill>
                 <a:latin typeface="Calibri" pitchFamily="34" charset="0"/>
                 <a:ea typeface="Calibri" pitchFamily="34" charset="-122"/>
@@ -7432,7 +7432,7 @@
             </a:avLst>
           </a:prstGeom>
           <a:solidFill>
-            <a:srgbClr val="0F211B"/>
+            <a:srgbClr val="0B1F1A"/>
           </a:solidFill>
           <a:ln/>
         </p:spPr>
@@ -7506,7 +7506,7 @@
             <a:r>
               <a:rPr lang="en-US" sz="1300" dirty="0">
                 <a:solidFill>
-                  <a:srgbClr val="DFEEE6"/>
+                  <a:srgbClr val="E6F0EC"/>
                 </a:solidFill>
                 <a:latin typeface="Calibri" pitchFamily="34" charset="0"/>
                 <a:ea typeface="Calibri" pitchFamily="34" charset="-122"/>
@@ -7532,7 +7532,7 @@
     <p:bg>
       <p:bgPr>
         <a:solidFill>
-          <a:srgbClr val="F4F6F3"/>
+          <a:srgbClr val="FFFFFF"/>
         </a:solidFill>
       </p:bgPr>
     </p:bg>
@@ -7577,7 +7577,7 @@
             <a:r>
               <a:rPr lang="en-US" sz="1100" b="1" spc="200" kern="0" dirty="0">
                 <a:solidFill>
-                  <a:srgbClr val="0B6E4F"/>
+                  <a:srgbClr val="05614A"/>
                 </a:solidFill>
                 <a:latin typeface="Calibri" pitchFamily="34" charset="0"/>
                 <a:ea typeface="Calibri" pitchFamily="34" charset="-122"/>
@@ -7616,7 +7616,7 @@
             <a:r>
               <a:rPr lang="en-US" sz="3400" b="1" dirty="0">
                 <a:solidFill>
-                  <a:srgbClr val="0F211B"/>
+                  <a:srgbClr val="141414"/>
                 </a:solidFill>
                 <a:latin typeface="Cambria" pitchFamily="34" charset="0"/>
                 <a:ea typeface="Cambria" pitchFamily="34" charset="-122"/>
@@ -7649,7 +7649,7 @@
           </a:solidFill>
           <a:ln w="9525">
             <a:solidFill>
-              <a:srgbClr val="D9E0D8"/>
+              <a:srgbClr val="D3DAD7"/>
             </a:solidFill>
             <a:prstDash val="solid"/>
           </a:ln>
@@ -7682,7 +7682,7 @@
             <a:r>
               <a:rPr lang="en-US" sz="2100" b="1" dirty="0">
                 <a:solidFill>
-                  <a:srgbClr val="0F211B"/>
+                  <a:srgbClr val="141414"/>
                 </a:solidFill>
                 <a:latin typeface="Cambria" pitchFamily="34" charset="0"/>
                 <a:ea typeface="Cambria" pitchFamily="34" charset="-122"/>
@@ -7724,7 +7724,7 @@
             <a:r>
               <a:rPr lang="en-US" sz="1350" dirty="0">
                 <a:solidFill>
-                  <a:srgbClr val="4E5C56"/>
+                  <a:srgbClr val="3F4A46"/>
                 </a:solidFill>
                 <a:latin typeface="Calibri" pitchFamily="34" charset="0"/>
                 <a:ea typeface="Calibri" pitchFamily="34" charset="-122"/>
@@ -7753,7 +7753,7 @@
             </a:avLst>
           </a:prstGeom>
           <a:solidFill>
-            <a:srgbClr val="DFEEE6"/>
+            <a:srgbClr val="E6F0EC"/>
           </a:solidFill>
           <a:ln/>
         </p:spPr>
@@ -7788,7 +7788,7 @@
             <a:r>
               <a:rPr lang="en-US" sz="1250" dirty="0">
                 <a:solidFill>
-                  <a:srgbClr val="0B6E4F"/>
+                  <a:srgbClr val="05614A"/>
                 </a:solidFill>
                 <a:latin typeface="Calibri" pitchFamily="34" charset="0"/>
                 <a:ea typeface="Calibri" pitchFamily="34" charset="-122"/>
@@ -7821,7 +7821,7 @@
           </a:solidFill>
           <a:ln w="9525">
             <a:solidFill>
-              <a:srgbClr val="D9E0D8"/>
+              <a:srgbClr val="D3DAD7"/>
             </a:solidFill>
             <a:prstDash val="solid"/>
           </a:ln>
@@ -7854,7 +7854,7 @@
             <a:r>
               <a:rPr lang="en-US" sz="2100" b="1" dirty="0">
                 <a:solidFill>
-                  <a:srgbClr val="0F211B"/>
+                  <a:srgbClr val="141414"/>
                 </a:solidFill>
                 <a:latin typeface="Cambria" pitchFamily="34" charset="0"/>
                 <a:ea typeface="Cambria" pitchFamily="34" charset="-122"/>
@@ -7896,7 +7896,7 @@
             <a:r>
               <a:rPr lang="en-US" sz="1350" dirty="0">
                 <a:solidFill>
-                  <a:srgbClr val="4E5C56"/>
+                  <a:srgbClr val="3F4A46"/>
                 </a:solidFill>
                 <a:latin typeface="Calibri" pitchFamily="34" charset="0"/>
                 <a:ea typeface="Calibri" pitchFamily="34" charset="-122"/>
@@ -7925,7 +7925,7 @@
             </a:avLst>
           </a:prstGeom>
           <a:solidFill>
-            <a:srgbClr val="DFEEE6"/>
+            <a:srgbClr val="E6F0EC"/>
           </a:solidFill>
           <a:ln/>
         </p:spPr>
@@ -7960,7 +7960,7 @@
             <a:r>
               <a:rPr lang="en-US" sz="1250" dirty="0">
                 <a:solidFill>
-                  <a:srgbClr val="0B6E4F"/>
+                  <a:srgbClr val="05614A"/>
                 </a:solidFill>
                 <a:latin typeface="Calibri" pitchFamily="34" charset="0"/>
                 <a:ea typeface="Calibri" pitchFamily="34" charset="-122"/>
@@ -7986,7 +7986,7 @@
     <p:bg>
       <p:bgPr>
         <a:solidFill>
-          <a:srgbClr val="F4F6F3"/>
+          <a:srgbClr val="FFFFFF"/>
         </a:solidFill>
       </p:bgPr>
     </p:bg>
@@ -8031,7 +8031,7 @@
             <a:r>
               <a:rPr lang="en-US" sz="1100" b="1" spc="200" kern="0" dirty="0">
                 <a:solidFill>
-                  <a:srgbClr val="0B6E4F"/>
+                  <a:srgbClr val="05614A"/>
                 </a:solidFill>
                 <a:latin typeface="Calibri" pitchFamily="34" charset="0"/>
                 <a:ea typeface="Calibri" pitchFamily="34" charset="-122"/>
@@ -8070,7 +8070,7 @@
             <a:r>
               <a:rPr lang="en-US" sz="3400" b="1" dirty="0">
                 <a:solidFill>
-                  <a:srgbClr val="0F211B"/>
+                  <a:srgbClr val="141414"/>
                 </a:solidFill>
                 <a:latin typeface="Cambria" pitchFamily="34" charset="0"/>
                 <a:ea typeface="Cambria" pitchFamily="34" charset="-122"/>
@@ -8112,7 +8112,7 @@
             <a:r>
               <a:rPr lang="en-US" sz="1500" dirty="0">
                 <a:solidFill>
-                  <a:srgbClr val="4E5C56"/>
+                  <a:srgbClr val="3F4A46"/>
                 </a:solidFill>
                 <a:latin typeface="Calibri" pitchFamily="34" charset="0"/>
                 <a:ea typeface="Calibri" pitchFamily="34" charset="-122"/>
@@ -8161,7 +8161,7 @@
           </a:solidFill>
           <a:ln w="9525">
             <a:solidFill>
-              <a:srgbClr val="D9E0D8"/>
+              <a:srgbClr val="D3DAD7"/>
             </a:solidFill>
             <a:prstDash val="solid"/>
           </a:ln>
@@ -8194,7 +8194,7 @@
             <a:r>
               <a:rPr lang="en-US" sz="2400" b="1" dirty="0">
                 <a:solidFill>
-                  <a:srgbClr val="0B6E4F"/>
+                  <a:srgbClr val="05614A"/>
                 </a:solidFill>
                 <a:latin typeface="Cambria" pitchFamily="34" charset="0"/>
                 <a:ea typeface="Cambria" pitchFamily="34" charset="-122"/>
@@ -8233,7 +8233,7 @@
             <a:r>
               <a:rPr lang="en-US" sz="1250" b="1" dirty="0">
                 <a:solidFill>
-                  <a:srgbClr val="0F211B"/>
+                  <a:srgbClr val="141414"/>
                 </a:solidFill>
                 <a:latin typeface="Calibri" pitchFamily="34" charset="0"/>
                 <a:ea typeface="Calibri" pitchFamily="34" charset="-122"/>
@@ -8272,7 +8272,7 @@
             <a:r>
               <a:rPr lang="en-US" sz="1100" dirty="0">
                 <a:solidFill>
-                  <a:srgbClr val="9FADA6"/>
+                  <a:srgbClr val="646E6A"/>
                 </a:solidFill>
                 <a:latin typeface="Calibri" pitchFamily="34" charset="0"/>
                 <a:ea typeface="Calibri" pitchFamily="34" charset="-122"/>
@@ -8305,7 +8305,7 @@
           </a:solidFill>
           <a:ln w="9525">
             <a:solidFill>
-              <a:srgbClr val="D9E0D8"/>
+              <a:srgbClr val="D3DAD7"/>
             </a:solidFill>
             <a:prstDash val="solid"/>
           </a:ln>
@@ -8338,7 +8338,7 @@
             <a:r>
               <a:rPr lang="en-US" sz="2400" b="1" dirty="0">
                 <a:solidFill>
-                  <a:srgbClr val="0B6E4F"/>
+                  <a:srgbClr val="05614A"/>
                 </a:solidFill>
                 <a:latin typeface="Cambria" pitchFamily="34" charset="0"/>
                 <a:ea typeface="Cambria" pitchFamily="34" charset="-122"/>
@@ -8377,7 +8377,7 @@
             <a:r>
               <a:rPr lang="en-US" sz="1250" b="1" dirty="0">
                 <a:solidFill>
-                  <a:srgbClr val="0F211B"/>
+                  <a:srgbClr val="141414"/>
                 </a:solidFill>
                 <a:latin typeface="Calibri" pitchFamily="34" charset="0"/>
                 <a:ea typeface="Calibri" pitchFamily="34" charset="-122"/>
@@ -8416,7 +8416,7 @@
             <a:r>
               <a:rPr lang="en-US" sz="1100" dirty="0">
                 <a:solidFill>
-                  <a:srgbClr val="9FADA6"/>
+                  <a:srgbClr val="646E6A"/>
                 </a:solidFill>
                 <a:latin typeface="Calibri" pitchFamily="34" charset="0"/>
                 <a:ea typeface="Calibri" pitchFamily="34" charset="-122"/>
@@ -8449,7 +8449,7 @@
           </a:solidFill>
           <a:ln w="9525">
             <a:solidFill>
-              <a:srgbClr val="D9E0D8"/>
+              <a:srgbClr val="D3DAD7"/>
             </a:solidFill>
             <a:prstDash val="solid"/>
           </a:ln>
@@ -8482,7 +8482,7 @@
             <a:r>
               <a:rPr lang="en-US" sz="2400" b="1" dirty="0">
                 <a:solidFill>
-                  <a:srgbClr val="0B6E4F"/>
+                  <a:srgbClr val="05614A"/>
                 </a:solidFill>
                 <a:latin typeface="Cambria" pitchFamily="34" charset="0"/>
                 <a:ea typeface="Cambria" pitchFamily="34" charset="-122"/>
@@ -8521,7 +8521,7 @@
             <a:r>
               <a:rPr lang="en-US" sz="1250" b="1" dirty="0">
                 <a:solidFill>
-                  <a:srgbClr val="0F211B"/>
+                  <a:srgbClr val="141414"/>
                 </a:solidFill>
                 <a:latin typeface="Calibri" pitchFamily="34" charset="0"/>
                 <a:ea typeface="Calibri" pitchFamily="34" charset="-122"/>
@@ -8560,7 +8560,7 @@
             <a:r>
               <a:rPr lang="en-US" sz="1100" dirty="0">
                 <a:solidFill>
-                  <a:srgbClr val="9FADA6"/>
+                  <a:srgbClr val="646E6A"/>
                 </a:solidFill>
                 <a:latin typeface="Calibri" pitchFamily="34" charset="0"/>
                 <a:ea typeface="Calibri" pitchFamily="34" charset="-122"/>
@@ -8586,7 +8586,7 @@
     <p:bg>
       <p:bgPr>
         <a:solidFill>
-          <a:srgbClr val="F4F6F3"/>
+          <a:srgbClr val="FFFFFF"/>
         </a:solidFill>
       </p:bgPr>
     </p:bg>
@@ -8631,7 +8631,7 @@
             <a:r>
               <a:rPr lang="en-US" sz="1100" b="1" spc="200" kern="0" dirty="0">
                 <a:solidFill>
-                  <a:srgbClr val="0B6E4F"/>
+                  <a:srgbClr val="05614A"/>
                 </a:solidFill>
                 <a:latin typeface="Calibri" pitchFamily="34" charset="0"/>
                 <a:ea typeface="Calibri" pitchFamily="34" charset="-122"/>
@@ -8670,7 +8670,7 @@
             <a:r>
               <a:rPr lang="en-US" sz="3400" b="1" dirty="0">
                 <a:solidFill>
-                  <a:srgbClr val="0F211B"/>
+                  <a:srgbClr val="141414"/>
                 </a:solidFill>
                 <a:latin typeface="Cambria" pitchFamily="34" charset="0"/>
                 <a:ea typeface="Cambria" pitchFamily="34" charset="-122"/>
@@ -8712,7 +8712,7 @@
             <a:r>
               <a:rPr lang="en-US" sz="1500" dirty="0">
                 <a:solidFill>
-                  <a:srgbClr val="4E5C56"/>
+                  <a:srgbClr val="3F4A46"/>
                 </a:solidFill>
                 <a:latin typeface="Calibri" pitchFamily="34" charset="0"/>
                 <a:ea typeface="Calibri" pitchFamily="34" charset="-122"/>
@@ -8761,7 +8761,7 @@
           </a:solidFill>
           <a:ln w="9525">
             <a:solidFill>
-              <a:srgbClr val="D9E0D8"/>
+              <a:srgbClr val="D3DAD7"/>
             </a:solidFill>
             <a:prstDash val="solid"/>
           </a:ln>
@@ -8797,7 +8797,7 @@
             <a:r>
               <a:rPr lang="en-US" sz="1700" b="1" dirty="0">
                 <a:solidFill>
-                  <a:srgbClr val="0F211B"/>
+                  <a:srgbClr val="141414"/>
                 </a:solidFill>
                 <a:latin typeface="Cambria" pitchFamily="34" charset="0"/>
                 <a:ea typeface="Cambria" pitchFamily="34" charset="-122"/>
@@ -8839,7 +8839,7 @@
             <a:r>
               <a:rPr lang="en-US" sz="1250" dirty="0">
                 <a:solidFill>
-                  <a:srgbClr val="4E5C56"/>
+                  <a:srgbClr val="3F4A46"/>
                 </a:solidFill>
                 <a:latin typeface="Calibri" pitchFamily="34" charset="0"/>
                 <a:ea typeface="Calibri" pitchFamily="34" charset="-122"/>
@@ -8868,7 +8868,7 @@
             <a:r>
               <a:rPr lang="en-US" sz="1250" dirty="0">
                 <a:solidFill>
-                  <a:srgbClr val="4E5C56"/>
+                  <a:srgbClr val="3F4A46"/>
                 </a:solidFill>
                 <a:latin typeface="Calibri" pitchFamily="34" charset="0"/>
                 <a:ea typeface="Calibri" pitchFamily="34" charset="-122"/>
@@ -8897,7 +8897,7 @@
             <a:r>
               <a:rPr lang="en-US" sz="1250" dirty="0">
                 <a:solidFill>
-                  <a:srgbClr val="4E5C56"/>
+                  <a:srgbClr val="3F4A46"/>
                 </a:solidFill>
                 <a:latin typeface="Calibri" pitchFamily="34" charset="0"/>
                 <a:ea typeface="Calibri" pitchFamily="34" charset="-122"/>
@@ -8923,7 +8923,7 @@
     <p:bg>
       <p:bgPr>
         <a:solidFill>
-          <a:srgbClr val="F4F6F3"/>
+          <a:srgbClr val="FFFFFF"/>
         </a:solidFill>
       </p:bgPr>
     </p:bg>
@@ -8968,7 +8968,7 @@
             <a:r>
               <a:rPr lang="en-US" sz="1100" b="1" spc="200" kern="0" dirty="0">
                 <a:solidFill>
-                  <a:srgbClr val="0B6E4F"/>
+                  <a:srgbClr val="05614A"/>
                 </a:solidFill>
                 <a:latin typeface="Calibri" pitchFamily="34" charset="0"/>
                 <a:ea typeface="Calibri" pitchFamily="34" charset="-122"/>
@@ -9007,7 +9007,7 @@
             <a:r>
               <a:rPr lang="en-US" sz="3400" b="1" dirty="0">
                 <a:solidFill>
-                  <a:srgbClr val="0F211B"/>
+                  <a:srgbClr val="141414"/>
                 </a:solidFill>
                 <a:latin typeface="Cambria" pitchFamily="34" charset="0"/>
                 <a:ea typeface="Cambria" pitchFamily="34" charset="-122"/>
@@ -9049,7 +9049,7 @@
             <a:r>
               <a:rPr lang="en-US" sz="1500" dirty="0">
                 <a:solidFill>
-                  <a:srgbClr val="4E5C56"/>
+                  <a:srgbClr val="3F4A46"/>
                 </a:solidFill>
                 <a:latin typeface="Calibri" pitchFamily="34" charset="0"/>
                 <a:ea typeface="Calibri" pitchFamily="34" charset="-122"/>
@@ -9094,7 +9094,7 @@
             </a:avLst>
           </a:prstGeom>
           <a:solidFill>
-            <a:srgbClr val="0F211B"/>
+            <a:srgbClr val="0B1F1A"/>
           </a:solidFill>
           <a:ln/>
         </p:spPr>
@@ -9126,7 +9126,7 @@
             <a:r>
               <a:rPr lang="en-US" sz="3800" b="1" dirty="0">
                 <a:solidFill>
-                  <a:srgbClr val="9A5A0F"/>
+                  <a:srgbClr val="8A4A08"/>
                 </a:solidFill>
                 <a:latin typeface="Cambria" pitchFamily="34" charset="0"/>
                 <a:ea typeface="Cambria" pitchFamily="34" charset="-122"/>
@@ -9201,7 +9201,7 @@
           </a:solidFill>
           <a:ln w="9525">
             <a:solidFill>
-              <a:srgbClr val="D9E0D8"/>
+              <a:srgbClr val="D3DAD7"/>
             </a:solidFill>
             <a:prstDash val="solid"/>
           </a:ln>
@@ -9237,7 +9237,7 @@
             <a:r>
               <a:rPr lang="en-US" sz="1300" i="1" dirty="0">
                 <a:solidFill>
-                  <a:srgbClr val="4E5C56"/>
+                  <a:srgbClr val="3F4A46"/>
                 </a:solidFill>
                 <a:latin typeface="Calibri" pitchFamily="34" charset="0"/>
                 <a:ea typeface="Calibri" pitchFamily="34" charset="-122"/>

</xml_diff>